<commit_message>
add krakenkoffee part 9
</commit_message>
<xml_diff>
--- a/krakenkoffee/design/kraken_koffee_design.pptx
+++ b/krakenkoffee/design/kraken_koffee_design.pptx
@@ -5127,6 +5127,89 @@
           </a:prstGeom>
         </p:spPr>
       </p:pic>
+      <p:sp>
+        <p:nvSpPr>
+          <p:cNvPr id="4" name="TextBox 3">
+            <a:extLst>
+              <a:ext uri="{FF2B5EF4-FFF2-40B4-BE49-F238E27FC236}">
+                <a16:creationId xmlns:a16="http://schemas.microsoft.com/office/drawing/2014/main" id="{8CCA84B9-7725-2F3D-5ACF-321424D79019}"/>
+              </a:ext>
+            </a:extLst>
+          </p:cNvPr>
+          <p:cNvSpPr txBox="1"/>
+          <p:nvPr/>
+        </p:nvSpPr>
+        <p:spPr>
+          <a:xfrm>
+            <a:off x="8953500" y="27019331"/>
+            <a:ext cx="3371850" cy="369332"/>
+          </a:xfrm>
+          <a:prstGeom prst="rect">
+            <a:avLst/>
+          </a:prstGeom>
+          <a:noFill/>
+        </p:spPr>
+        <p:txBody>
+          <a:bodyPr wrap="square" rtlCol="0">
+            <a:spAutoFit/>
+          </a:bodyPr>
+          <a:lstStyle/>
+          <a:p>
+            <a:pPr algn="r"/>
+            <a:r>
+              <a:rPr lang="en-FI" sz="900" spc="300" dirty="0">
+                <a:ln w="0">
+                  <a:noFill/>
+                </a:ln>
+                <a:gradFill flip="none" rotWithShape="1">
+                  <a:gsLst>
+                    <a:gs pos="50000">
+                      <a:srgbClr val="60B687"/>
+                    </a:gs>
+                    <a:gs pos="0">
+                      <a:srgbClr val="007A72"/>
+                    </a:gs>
+                    <a:gs pos="100000">
+                      <a:srgbClr val="EBA129"/>
+                    </a:gs>
+                  </a:gsLst>
+                  <a:lin ang="0" scaled="1"/>
+                  <a:tileRect/>
+                </a:gradFill>
+                <a:latin typeface="Bahnschrift SemiCondensed" panose="020B0502040204020203" pitchFamily="34" charset="0"/>
+              </a:rPr>
+              <a:t>Developed by Toni Sundqvist</a:t>
+            </a:r>
+          </a:p>
+          <a:p>
+            <a:pPr algn="r"/>
+            <a:r>
+              <a:rPr lang="en-FI" sz="900" spc="300" dirty="0">
+                <a:ln w="0">
+                  <a:noFill/>
+                </a:ln>
+                <a:gradFill flip="none" rotWithShape="1">
+                  <a:gsLst>
+                    <a:gs pos="50000">
+                      <a:srgbClr val="60B687"/>
+                    </a:gs>
+                    <a:gs pos="0">
+                      <a:srgbClr val="007A72"/>
+                    </a:gs>
+                    <a:gs pos="100000">
+                      <a:srgbClr val="EBA129"/>
+                    </a:gs>
+                  </a:gsLst>
+                  <a:lin ang="0" scaled="1"/>
+                  <a:tileRect/>
+                </a:gradFill>
+                <a:latin typeface="Bahnschrift SemiCondensed" panose="020B0502040204020203" pitchFamily="34" charset="0"/>
+              </a:rPr>
+              <a:t>Project by Sean Chandler</a:t>
+            </a:r>
+          </a:p>
+        </p:txBody>
+      </p:sp>
     </p:spTree>
     <p:extLst>
       <p:ext uri="{BB962C8B-B14F-4D97-AF65-F5344CB8AC3E}">

</xml_diff>